<commit_message>
Deck 3: use n for sample size in CI formula
Co-Authored-By: Claude Opus 5.5 <noreply@anthropic.com>
</commit_message>
<xml_diff>
--- a/lectures/presentation/notebook_3_KPIs.pptx
+++ b/lectures/presentation/notebook_3_KPIs.pptx
@@ -4,6 +4,9 @@
   <p:sldMasterIdLst>
     <p:sldMasterId id="2147483648" r:id="rId1"/>
   </p:sldMasterIdLst>
+  <p:notesMasterIdLst>
+    <p:notesMasterId r:id="rId24"/>
+  </p:notesMasterIdLst>
   <p:sldIdLst>
     <p:sldId id="256" r:id="rId2"/>
     <p:sldId id="257" r:id="rId3"/>
@@ -144,6 +147,524 @@
 </p:presentation>
 </file>
 
+<file path=ppt/notesMasters/notesMaster1.xml><?xml version="1.0" encoding="utf-8"?>
+<p:notesMaster xmlns:a="http://schemas.openxmlformats.org/drawingml/2006/main" xmlns:r="http://schemas.openxmlformats.org/officeDocument/2006/relationships" xmlns:p="http://schemas.openxmlformats.org/presentationml/2006/main">
+  <p:cSld>
+    <p:bg>
+      <p:bgRef idx="1001">
+        <a:schemeClr val="bg1"/>
+      </p:bgRef>
+    </p:bg>
+    <p:spTree>
+      <p:nvGrpSpPr>
+        <p:cNvPr id="1" name=""/>
+        <p:cNvGrpSpPr/>
+        <p:nvPr/>
+      </p:nvGrpSpPr>
+      <p:grpSpPr>
+        <a:xfrm>
+          <a:off x="0" y="0"/>
+          <a:ext cx="0" cy="0"/>
+          <a:chOff x="0" y="0"/>
+          <a:chExt cx="0" cy="0"/>
+        </a:xfrm>
+      </p:grpSpPr>
+      <p:sp>
+        <p:nvSpPr>
+          <p:cNvPr id="2" name="Header Placeholder 1"/>
+          <p:cNvSpPr>
+            <a:spLocks noGrp="1"/>
+          </p:cNvSpPr>
+          <p:nvPr>
+            <p:ph type="hdr" sz="quarter"/>
+          </p:nvPr>
+        </p:nvSpPr>
+        <p:spPr>
+          <a:xfrm>
+            <a:off x="0" y="0"/>
+            <a:ext cx="2971800" cy="458788"/>
+          </a:xfrm>
+          <a:prstGeom prst="rect">
+            <a:avLst/>
+          </a:prstGeom>
+        </p:spPr>
+        <p:txBody>
+          <a:bodyPr vert="horz" lIns="91440" tIns="45720" rIns="91440" bIns="45720" rtlCol="0"/>
+          <a:lstStyle>
+            <a:lvl1pPr algn="l">
+              <a:defRPr sz="1200"/>
+            </a:lvl1pPr>
+          </a:lstStyle>
+          <a:p>
+            <a:endParaRPr lang="en-IL"/>
+          </a:p>
+        </p:txBody>
+      </p:sp>
+      <p:sp>
+        <p:nvSpPr>
+          <p:cNvPr id="3" name="Date Placeholder 2"/>
+          <p:cNvSpPr>
+            <a:spLocks noGrp="1"/>
+          </p:cNvSpPr>
+          <p:nvPr>
+            <p:ph type="dt" idx="1"/>
+          </p:nvPr>
+        </p:nvSpPr>
+        <p:spPr>
+          <a:xfrm>
+            <a:off x="3884613" y="0"/>
+            <a:ext cx="2971800" cy="458788"/>
+          </a:xfrm>
+          <a:prstGeom prst="rect">
+            <a:avLst/>
+          </a:prstGeom>
+        </p:spPr>
+        <p:txBody>
+          <a:bodyPr vert="horz" lIns="91440" tIns="45720" rIns="91440" bIns="45720" rtlCol="0"/>
+          <a:lstStyle>
+            <a:lvl1pPr algn="r">
+              <a:defRPr sz="1200"/>
+            </a:lvl1pPr>
+          </a:lstStyle>
+          <a:p>
+            <a:fld id="{B7361A16-4452-484D-8EDB-6DE49DF7E612}" type="datetimeFigureOut">
+              <a:rPr lang="en-IL" smtClean="0"/>
+              <a:t>28/10/2026</a:t>
+            </a:fld>
+            <a:endParaRPr lang="en-IL"/>
+          </a:p>
+        </p:txBody>
+      </p:sp>
+      <p:sp>
+        <p:nvSpPr>
+          <p:cNvPr id="4" name="Slide Image Placeholder 3"/>
+          <p:cNvSpPr>
+            <a:spLocks noGrp="1" noRot="1" noChangeAspect="1"/>
+          </p:cNvSpPr>
+          <p:nvPr>
+            <p:ph type="sldImg" idx="2"/>
+          </p:nvPr>
+        </p:nvSpPr>
+        <p:spPr>
+          <a:xfrm>
+            <a:off x="685800" y="1143000"/>
+            <a:ext cx="5486400" cy="3086100"/>
+          </a:xfrm>
+          <a:prstGeom prst="rect">
+            <a:avLst/>
+          </a:prstGeom>
+          <a:noFill/>
+          <a:ln w="12700">
+            <a:solidFill>
+              <a:prstClr val="black"/>
+            </a:solidFill>
+          </a:ln>
+        </p:spPr>
+        <p:txBody>
+          <a:bodyPr vert="horz" lIns="91440" tIns="45720" rIns="91440" bIns="45720" rtlCol="0" anchor="ctr"/>
+          <a:lstStyle/>
+          <a:p>
+            <a:endParaRPr lang="en-IL"/>
+          </a:p>
+        </p:txBody>
+      </p:sp>
+      <p:sp>
+        <p:nvSpPr>
+          <p:cNvPr id="5" name="Notes Placeholder 4"/>
+          <p:cNvSpPr>
+            <a:spLocks noGrp="1"/>
+          </p:cNvSpPr>
+          <p:nvPr>
+            <p:ph type="body" sz="quarter" idx="3"/>
+          </p:nvPr>
+        </p:nvSpPr>
+        <p:spPr>
+          <a:xfrm>
+            <a:off x="685800" y="4400550"/>
+            <a:ext cx="5486400" cy="3600450"/>
+          </a:xfrm>
+          <a:prstGeom prst="rect">
+            <a:avLst/>
+          </a:prstGeom>
+        </p:spPr>
+        <p:txBody>
+          <a:bodyPr vert="horz" lIns="91440" tIns="45720" rIns="91440" bIns="45720" rtlCol="0"/>
+          <a:lstStyle/>
+          <a:p>
+            <a:pPr lvl="0"/>
+            <a:r>
+              <a:rPr lang="en-US"/>
+              <a:t>Click to edit Master text styles</a:t>
+            </a:r>
+          </a:p>
+          <a:p>
+            <a:pPr lvl="1"/>
+            <a:r>
+              <a:rPr lang="en-US"/>
+              <a:t>Second level</a:t>
+            </a:r>
+          </a:p>
+          <a:p>
+            <a:pPr lvl="2"/>
+            <a:r>
+              <a:rPr lang="en-US"/>
+              <a:t>Third level</a:t>
+            </a:r>
+          </a:p>
+          <a:p>
+            <a:pPr lvl="3"/>
+            <a:r>
+              <a:rPr lang="en-US"/>
+              <a:t>Fourth level</a:t>
+            </a:r>
+          </a:p>
+          <a:p>
+            <a:pPr lvl="4"/>
+            <a:r>
+              <a:rPr lang="en-US"/>
+              <a:t>Fifth level</a:t>
+            </a:r>
+            <a:endParaRPr lang="en-IL"/>
+          </a:p>
+        </p:txBody>
+      </p:sp>
+      <p:sp>
+        <p:nvSpPr>
+          <p:cNvPr id="6" name="Footer Placeholder 5"/>
+          <p:cNvSpPr>
+            <a:spLocks noGrp="1"/>
+          </p:cNvSpPr>
+          <p:nvPr>
+            <p:ph type="ftr" sz="quarter" idx="4"/>
+          </p:nvPr>
+        </p:nvSpPr>
+        <p:spPr>
+          <a:xfrm>
+            <a:off x="0" y="8685213"/>
+            <a:ext cx="2971800" cy="458787"/>
+          </a:xfrm>
+          <a:prstGeom prst="rect">
+            <a:avLst/>
+          </a:prstGeom>
+        </p:spPr>
+        <p:txBody>
+          <a:bodyPr vert="horz" lIns="91440" tIns="45720" rIns="91440" bIns="45720" rtlCol="0" anchor="b"/>
+          <a:lstStyle>
+            <a:lvl1pPr algn="l">
+              <a:defRPr sz="1200"/>
+            </a:lvl1pPr>
+          </a:lstStyle>
+          <a:p>
+            <a:endParaRPr lang="en-IL"/>
+          </a:p>
+        </p:txBody>
+      </p:sp>
+      <p:sp>
+        <p:nvSpPr>
+          <p:cNvPr id="7" name="Slide Number Placeholder 6"/>
+          <p:cNvSpPr>
+            <a:spLocks noGrp="1"/>
+          </p:cNvSpPr>
+          <p:nvPr>
+            <p:ph type="sldNum" sz="quarter" idx="5"/>
+          </p:nvPr>
+        </p:nvSpPr>
+        <p:spPr>
+          <a:xfrm>
+            <a:off x="3884613" y="8685213"/>
+            <a:ext cx="2971800" cy="458787"/>
+          </a:xfrm>
+          <a:prstGeom prst="rect">
+            <a:avLst/>
+          </a:prstGeom>
+        </p:spPr>
+        <p:txBody>
+          <a:bodyPr vert="horz" lIns="91440" tIns="45720" rIns="91440" bIns="45720" rtlCol="0" anchor="b"/>
+          <a:lstStyle>
+            <a:lvl1pPr algn="r">
+              <a:defRPr sz="1200"/>
+            </a:lvl1pPr>
+          </a:lstStyle>
+          <a:p>
+            <a:fld id="{51218E80-464F-43DD-9451-D0D0FA5D837E}" type="slidenum">
+              <a:rPr lang="en-IL" smtClean="0"/>
+              <a:t>‹#›</a:t>
+            </a:fld>
+            <a:endParaRPr lang="en-IL"/>
+          </a:p>
+        </p:txBody>
+      </p:sp>
+    </p:spTree>
+    <p:extLst>
+      <p:ext uri="{BB962C8B-B14F-4D97-AF65-F5344CB8AC3E}">
+        <p14:creationId xmlns:p14="http://schemas.microsoft.com/office/powerpoint/2010/main" val="4077579183"/>
+      </p:ext>
+    </p:extLst>
+  </p:cSld>
+  <p:clrMap bg1="lt1" tx1="dk1" bg2="lt2" tx2="dk2" accent1="accent1" accent2="accent2" accent3="accent3" accent4="accent4" accent5="accent5" accent6="accent6" hlink="hlink" folHlink="folHlink"/>
+  <p:notesStyle>
+    <a:lvl1pPr marL="0" algn="l" defTabSz="914400" rtl="0" eaLnBrk="1" latinLnBrk="0" hangingPunct="1">
+      <a:defRPr sz="1200" kern="1200">
+        <a:solidFill>
+          <a:schemeClr val="tx1"/>
+        </a:solidFill>
+        <a:latin typeface="+mn-lt"/>
+        <a:ea typeface="+mn-ea"/>
+        <a:cs typeface="+mn-cs"/>
+      </a:defRPr>
+    </a:lvl1pPr>
+    <a:lvl2pPr marL="457200" algn="l" defTabSz="914400" rtl="0" eaLnBrk="1" latinLnBrk="0" hangingPunct="1">
+      <a:defRPr sz="1200" kern="1200">
+        <a:solidFill>
+          <a:schemeClr val="tx1"/>
+        </a:solidFill>
+        <a:latin typeface="+mn-lt"/>
+        <a:ea typeface="+mn-ea"/>
+        <a:cs typeface="+mn-cs"/>
+      </a:defRPr>
+    </a:lvl2pPr>
+    <a:lvl3pPr marL="914400" algn="l" defTabSz="914400" rtl="0" eaLnBrk="1" latinLnBrk="0" hangingPunct="1">
+      <a:defRPr sz="1200" kern="1200">
+        <a:solidFill>
+          <a:schemeClr val="tx1"/>
+        </a:solidFill>
+        <a:latin typeface="+mn-lt"/>
+        <a:ea typeface="+mn-ea"/>
+        <a:cs typeface="+mn-cs"/>
+      </a:defRPr>
+    </a:lvl3pPr>
+    <a:lvl4pPr marL="1371600" algn="l" defTabSz="914400" rtl="0" eaLnBrk="1" latinLnBrk="0" hangingPunct="1">
+      <a:defRPr sz="1200" kern="1200">
+        <a:solidFill>
+          <a:schemeClr val="tx1"/>
+        </a:solidFill>
+        <a:latin typeface="+mn-lt"/>
+        <a:ea typeface="+mn-ea"/>
+        <a:cs typeface="+mn-cs"/>
+      </a:defRPr>
+    </a:lvl4pPr>
+    <a:lvl5pPr marL="1828800" algn="l" defTabSz="914400" rtl="0" eaLnBrk="1" latinLnBrk="0" hangingPunct="1">
+      <a:defRPr sz="1200" kern="1200">
+        <a:solidFill>
+          <a:schemeClr val="tx1"/>
+        </a:solidFill>
+        <a:latin typeface="+mn-lt"/>
+        <a:ea typeface="+mn-ea"/>
+        <a:cs typeface="+mn-cs"/>
+      </a:defRPr>
+    </a:lvl5pPr>
+    <a:lvl6pPr marL="2286000" algn="l" defTabSz="914400" rtl="0" eaLnBrk="1" latinLnBrk="0" hangingPunct="1">
+      <a:defRPr sz="1200" kern="1200">
+        <a:solidFill>
+          <a:schemeClr val="tx1"/>
+        </a:solidFill>
+        <a:latin typeface="+mn-lt"/>
+        <a:ea typeface="+mn-ea"/>
+        <a:cs typeface="+mn-cs"/>
+      </a:defRPr>
+    </a:lvl6pPr>
+    <a:lvl7pPr marL="2743200" algn="l" defTabSz="914400" rtl="0" eaLnBrk="1" latinLnBrk="0" hangingPunct="1">
+      <a:defRPr sz="1200" kern="1200">
+        <a:solidFill>
+          <a:schemeClr val="tx1"/>
+        </a:solidFill>
+        <a:latin typeface="+mn-lt"/>
+        <a:ea typeface="+mn-ea"/>
+        <a:cs typeface="+mn-cs"/>
+      </a:defRPr>
+    </a:lvl7pPr>
+    <a:lvl8pPr marL="3200400" algn="l" defTabSz="914400" rtl="0" eaLnBrk="1" latinLnBrk="0" hangingPunct="1">
+      <a:defRPr sz="1200" kern="1200">
+        <a:solidFill>
+          <a:schemeClr val="tx1"/>
+        </a:solidFill>
+        <a:latin typeface="+mn-lt"/>
+        <a:ea typeface="+mn-ea"/>
+        <a:cs typeface="+mn-cs"/>
+      </a:defRPr>
+    </a:lvl8pPr>
+    <a:lvl9pPr marL="3657600" algn="l" defTabSz="914400" rtl="0" eaLnBrk="1" latinLnBrk="0" hangingPunct="1">
+      <a:defRPr sz="1200" kern="1200">
+        <a:solidFill>
+          <a:schemeClr val="tx1"/>
+        </a:solidFill>
+        <a:latin typeface="+mn-lt"/>
+        <a:ea typeface="+mn-ea"/>
+        <a:cs typeface="+mn-cs"/>
+      </a:defRPr>
+    </a:lvl9pPr>
+  </p:notesStyle>
+</p:notesMaster>
+</file>
+
+<file path=ppt/notesSlides/notesSlide1.xml><?xml version="1.0" encoding="utf-8"?>
+<p:notes xmlns:a="http://schemas.openxmlformats.org/drawingml/2006/main" xmlns:r="http://schemas.openxmlformats.org/officeDocument/2006/relationships" xmlns:p="http://schemas.openxmlformats.org/presentationml/2006/main">
+  <p:cSld>
+    <p:spTree>
+      <p:nvGrpSpPr>
+        <p:cNvPr id="1" name=""/>
+        <p:cNvGrpSpPr/>
+        <p:nvPr/>
+      </p:nvGrpSpPr>
+      <p:grpSpPr>
+        <a:xfrm>
+          <a:off x="0" y="0"/>
+          <a:ext cx="0" cy="0"/>
+          <a:chOff x="0" y="0"/>
+          <a:chExt cx="0" cy="0"/>
+        </a:xfrm>
+      </p:grpSpPr>
+      <p:sp>
+        <p:nvSpPr>
+          <p:cNvPr id="2" name="Slide Image Placeholder 1"/>
+          <p:cNvSpPr>
+            <a:spLocks noGrp="1" noRot="1" noChangeAspect="1"/>
+          </p:cNvSpPr>
+          <p:nvPr>
+            <p:ph type="sldImg"/>
+          </p:nvPr>
+        </p:nvSpPr>
+        <p:spPr/>
+      </p:sp>
+      <p:sp>
+        <p:nvSpPr>
+          <p:cNvPr id="3" name="Notes Placeholder 2"/>
+          <p:cNvSpPr>
+            <a:spLocks noGrp="1"/>
+          </p:cNvSpPr>
+          <p:nvPr>
+            <p:ph type="body" idx="1"/>
+          </p:nvPr>
+        </p:nvSpPr>
+        <p:spPr/>
+        <p:txBody>
+          <a:bodyPr/>
+          <a:lstStyle/>
+          <a:p>
+            <a:endParaRPr lang="en-IL" dirty="0"/>
+          </a:p>
+        </p:txBody>
+      </p:sp>
+      <p:sp>
+        <p:nvSpPr>
+          <p:cNvPr id="4" name="Slide Number Placeholder 3"/>
+          <p:cNvSpPr>
+            <a:spLocks noGrp="1"/>
+          </p:cNvSpPr>
+          <p:nvPr>
+            <p:ph type="sldNum" sz="quarter" idx="5"/>
+          </p:nvPr>
+        </p:nvSpPr>
+        <p:spPr/>
+        <p:txBody>
+          <a:bodyPr/>
+          <a:lstStyle/>
+          <a:p>
+            <a:fld id="{51218E80-464F-43DD-9451-D0D0FA5D837E}" type="slidenum">
+              <a:rPr lang="en-IL" smtClean="0"/>
+              <a:t>4</a:t>
+            </a:fld>
+            <a:endParaRPr lang="en-IL"/>
+          </a:p>
+        </p:txBody>
+      </p:sp>
+    </p:spTree>
+    <p:extLst>
+      <p:ext uri="{BB962C8B-B14F-4D97-AF65-F5344CB8AC3E}">
+        <p14:creationId xmlns:p14="http://schemas.microsoft.com/office/powerpoint/2010/main" val="4023744809"/>
+      </p:ext>
+    </p:extLst>
+  </p:cSld>
+  <p:clrMapOvr>
+    <a:masterClrMapping/>
+  </p:clrMapOvr>
+</p:notes>
+</file>
+
+<file path=ppt/notesSlides/notesSlide2.xml><?xml version="1.0" encoding="utf-8"?>
+<p:notes xmlns:a="http://schemas.openxmlformats.org/drawingml/2006/main" xmlns:r="http://schemas.openxmlformats.org/officeDocument/2006/relationships" xmlns:p="http://schemas.openxmlformats.org/presentationml/2006/main">
+  <p:cSld>
+    <p:spTree>
+      <p:nvGrpSpPr>
+        <p:cNvPr id="1" name=""/>
+        <p:cNvGrpSpPr/>
+        <p:nvPr/>
+      </p:nvGrpSpPr>
+      <p:grpSpPr>
+        <a:xfrm>
+          <a:off x="0" y="0"/>
+          <a:ext cx="0" cy="0"/>
+          <a:chOff x="0" y="0"/>
+          <a:chExt cx="0" cy="0"/>
+        </a:xfrm>
+      </p:grpSpPr>
+      <p:sp>
+        <p:nvSpPr>
+          <p:cNvPr id="2" name="Slide Image Placeholder 1"/>
+          <p:cNvSpPr>
+            <a:spLocks noGrp="1" noRot="1" noChangeAspect="1"/>
+          </p:cNvSpPr>
+          <p:nvPr>
+            <p:ph type="sldImg"/>
+          </p:nvPr>
+        </p:nvSpPr>
+        <p:spPr/>
+      </p:sp>
+      <p:sp>
+        <p:nvSpPr>
+          <p:cNvPr id="3" name="Notes Placeholder 2"/>
+          <p:cNvSpPr>
+            <a:spLocks noGrp="1"/>
+          </p:cNvSpPr>
+          <p:nvPr>
+            <p:ph type="body" idx="1"/>
+          </p:nvPr>
+        </p:nvSpPr>
+        <p:spPr/>
+        <p:txBody>
+          <a:bodyPr/>
+          <a:lstStyle/>
+          <a:p>
+            <a:endParaRPr lang="en-IL" dirty="0"/>
+          </a:p>
+        </p:txBody>
+      </p:sp>
+      <p:sp>
+        <p:nvSpPr>
+          <p:cNvPr id="4" name="Slide Number Placeholder 3"/>
+          <p:cNvSpPr>
+            <a:spLocks noGrp="1"/>
+          </p:cNvSpPr>
+          <p:nvPr>
+            <p:ph type="sldNum" sz="quarter" idx="5"/>
+          </p:nvPr>
+        </p:nvSpPr>
+        <p:spPr/>
+        <p:txBody>
+          <a:bodyPr/>
+          <a:lstStyle/>
+          <a:p>
+            <a:fld id="{51218E80-464F-43DD-9451-D0D0FA5D837E}" type="slidenum">
+              <a:rPr lang="en-IL" smtClean="0"/>
+              <a:t>12</a:t>
+            </a:fld>
+            <a:endParaRPr lang="en-IL"/>
+          </a:p>
+        </p:txBody>
+      </p:sp>
+    </p:spTree>
+    <p:extLst>
+      <p:ext uri="{BB962C8B-B14F-4D97-AF65-F5344CB8AC3E}">
+        <p14:creationId xmlns:p14="http://schemas.microsoft.com/office/powerpoint/2010/main" val="723617522"/>
+      </p:ext>
+    </p:extLst>
+  </p:cSld>
+  <p:clrMapOvr>
+    <a:masterClrMapping/>
+  </p:clrMapOvr>
+</p:notes>
+</file>
+
 <file path=ppt/slideLayouts/slideLayout1.xml><?xml version="1.0" encoding="utf-8"?>
 <p:sldLayout xmlns:a="http://schemas.openxmlformats.org/drawingml/2006/main" xmlns:r="http://schemas.openxmlformats.org/officeDocument/2006/relationships" xmlns:p="http://schemas.openxmlformats.org/presentationml/2006/main" type="title" preserve="1">
   <p:cSld name="Title Slide">
@@ -323,7 +844,7 @@
           <a:p>
             <a:fld id="{5BCAD085-E8A6-8845-BD4E-CB4CCA059FC4}" type="datetimeFigureOut">
               <a:rPr lang="en-US" smtClean="0"/>
-              <a:t>10/26/2026</a:t>
+              <a:t>10/28/2026</a:t>
             </a:fld>
             <a:endParaRPr lang="en-US"/>
           </a:p>
@@ -491,7 +1012,7 @@
           <a:p>
             <a:fld id="{5BCAD085-E8A6-8845-BD4E-CB4CCA059FC4}" type="datetimeFigureOut">
               <a:rPr lang="en-US" smtClean="0"/>
-              <a:t>10/26/2026</a:t>
+              <a:t>10/28/2026</a:t>
             </a:fld>
             <a:endParaRPr lang="en-US"/>
           </a:p>
@@ -669,7 +1190,7 @@
           <a:p>
             <a:fld id="{5BCAD085-E8A6-8845-BD4E-CB4CCA059FC4}" type="datetimeFigureOut">
               <a:rPr lang="en-US" smtClean="0"/>
-              <a:t>10/26/2026</a:t>
+              <a:t>10/28/2026</a:t>
             </a:fld>
             <a:endParaRPr lang="en-US"/>
           </a:p>
@@ -837,7 +1358,7 @@
           <a:p>
             <a:fld id="{5BCAD085-E8A6-8845-BD4E-CB4CCA059FC4}" type="datetimeFigureOut">
               <a:rPr lang="en-US" smtClean="0"/>
-              <a:t>10/26/2026</a:t>
+              <a:t>10/28/2026</a:t>
             </a:fld>
             <a:endParaRPr lang="en-US"/>
           </a:p>
@@ -1082,7 +1603,7 @@
           <a:p>
             <a:fld id="{5BCAD085-E8A6-8845-BD4E-CB4CCA059FC4}" type="datetimeFigureOut">
               <a:rPr lang="en-US" smtClean="0"/>
-              <a:t>10/26/2026</a:t>
+              <a:t>10/28/2026</a:t>
             </a:fld>
             <a:endParaRPr lang="en-US"/>
           </a:p>
@@ -1367,7 +1888,7 @@
           <a:p>
             <a:fld id="{5BCAD085-E8A6-8845-BD4E-CB4CCA059FC4}" type="datetimeFigureOut">
               <a:rPr lang="en-US" smtClean="0"/>
-              <a:t>10/26/2026</a:t>
+              <a:t>10/28/2026</a:t>
             </a:fld>
             <a:endParaRPr lang="en-US"/>
           </a:p>
@@ -1786,7 +2307,7 @@
           <a:p>
             <a:fld id="{5BCAD085-E8A6-8845-BD4E-CB4CCA059FC4}" type="datetimeFigureOut">
               <a:rPr lang="en-US" smtClean="0"/>
-              <a:t>10/26/2026</a:t>
+              <a:t>10/28/2026</a:t>
             </a:fld>
             <a:endParaRPr lang="en-US"/>
           </a:p>
@@ -1903,7 +2424,7 @@
           <a:p>
             <a:fld id="{5BCAD085-E8A6-8845-BD4E-CB4CCA059FC4}" type="datetimeFigureOut">
               <a:rPr lang="en-US" smtClean="0"/>
-              <a:t>10/26/2026</a:t>
+              <a:t>10/28/2026</a:t>
             </a:fld>
             <a:endParaRPr lang="en-US"/>
           </a:p>
@@ -1998,7 +2519,7 @@
           <a:p>
             <a:fld id="{5BCAD085-E8A6-8845-BD4E-CB4CCA059FC4}" type="datetimeFigureOut">
               <a:rPr lang="en-US" smtClean="0"/>
-              <a:t>10/26/2026</a:t>
+              <a:t>10/28/2026</a:t>
             </a:fld>
             <a:endParaRPr lang="en-US"/>
           </a:p>
@@ -2273,7 +2794,7 @@
           <a:p>
             <a:fld id="{5BCAD085-E8A6-8845-BD4E-CB4CCA059FC4}" type="datetimeFigureOut">
               <a:rPr lang="en-US" smtClean="0"/>
-              <a:t>10/26/2026</a:t>
+              <a:t>10/28/2026</a:t>
             </a:fld>
             <a:endParaRPr lang="en-US"/>
           </a:p>
@@ -2525,7 +3046,7 @@
           <a:p>
             <a:fld id="{5BCAD085-E8A6-8845-BD4E-CB4CCA059FC4}" type="datetimeFigureOut">
               <a:rPr lang="en-US" smtClean="0"/>
-              <a:t>10/26/2026</a:t>
+              <a:t>10/28/2026</a:t>
             </a:fld>
             <a:endParaRPr lang="en-US"/>
           </a:p>
@@ -2736,7 +3257,7 @@
           <a:p>
             <a:fld id="{5BCAD085-E8A6-8845-BD4E-CB4CCA059FC4}" type="datetimeFigureOut">
               <a:rPr lang="en-US" smtClean="0"/>
-              <a:t>10/26/2026</a:t>
+              <a:t>10/28/2026</a:t>
             </a:fld>
             <a:endParaRPr lang="en-US"/>
           </a:p>
@@ -4836,8 +5357,8 @@
         </p:nvSpPr>
         <p:spPr>
           <a:xfrm>
-            <a:off x="1371600" y="2377440"/>
-            <a:ext cx="9445752" cy="2743200"/>
+            <a:off x="1371600" y="3184077"/>
+            <a:ext cx="9445752" cy="1129925"/>
           </a:xfrm>
           <a:prstGeom prst="rect">
             <a:avLst/>
@@ -4862,7 +5383,7 @@
               </a:spcAft>
             </a:pPr>
             <a:r>
-              <a:rPr sz="2600" b="1" i="0">
+              <a:rPr sz="2600" b="1" i="0" dirty="0">
                 <a:solidFill>
                   <a:srgbClr val="2E86AB"/>
                 </a:solidFill>
@@ -4884,33 +5405,157 @@
               </a:spcAft>
             </a:pPr>
             <a:r>
-              <a:rPr sz="2600" b="1" i="0">
+              <a:rPr sz="2600" b="1" i="0" dirty="0" err="1">
                 <a:solidFill>
                   <a:srgbClr val="2E86AB"/>
                 </a:solidFill>
                 <a:latin typeface="Calibri"/>
               </a:rPr>
-              <a:t>השונות של האומד קטנה ככל שגודל המדגם</a:t>
-            </a:r>
-            <a:br/>
-            <a:r>
-              <a:rPr sz="2600" b="1" i="0">
+              <a:t>השונות</a:t>
+            </a:r>
+            <a:r>
+              <a:rPr sz="2600" b="1" i="0" dirty="0">
                 <a:solidFill>
                   <a:srgbClr val="2E86AB"/>
                 </a:solidFill>
                 <a:latin typeface="Calibri"/>
               </a:rPr>
-              <a:t>n</a:t>
-            </a:r>
-            <a:br/>
-            <a:r>
-              <a:rPr sz="2600" b="1" i="0">
+              <a:t> </a:t>
+            </a:r>
+            <a:r>
+              <a:rPr sz="2600" b="1" i="0" dirty="0" err="1">
                 <a:solidFill>
                   <a:srgbClr val="2E86AB"/>
                 </a:solidFill>
                 <a:latin typeface="Calibri"/>
               </a:rPr>
-              <a:t>גדל.</a:t>
+              <a:t>של</a:t>
+            </a:r>
+            <a:r>
+              <a:rPr sz="2600" b="1" i="0" dirty="0">
+                <a:solidFill>
+                  <a:srgbClr val="2E86AB"/>
+                </a:solidFill>
+                <a:latin typeface="Calibri"/>
+              </a:rPr>
+              <a:t> </a:t>
+            </a:r>
+            <a:r>
+              <a:rPr sz="2600" b="1" i="0" dirty="0" err="1">
+                <a:solidFill>
+                  <a:srgbClr val="2E86AB"/>
+                </a:solidFill>
+                <a:latin typeface="Calibri"/>
+              </a:rPr>
+              <a:t>האומד</a:t>
+            </a:r>
+            <a:r>
+              <a:rPr sz="2600" b="1" i="0" dirty="0">
+                <a:solidFill>
+                  <a:srgbClr val="2E86AB"/>
+                </a:solidFill>
+                <a:latin typeface="Calibri"/>
+              </a:rPr>
+              <a:t> </a:t>
+            </a:r>
+            <a:r>
+              <a:rPr sz="2600" b="1" i="0" dirty="0" err="1">
+                <a:solidFill>
+                  <a:srgbClr val="2E86AB"/>
+                </a:solidFill>
+                <a:latin typeface="Calibri"/>
+              </a:rPr>
+              <a:t>קטנה</a:t>
+            </a:r>
+            <a:r>
+              <a:rPr sz="2600" b="1" i="0" dirty="0">
+                <a:solidFill>
+                  <a:srgbClr val="2E86AB"/>
+                </a:solidFill>
+                <a:latin typeface="Calibri"/>
+              </a:rPr>
+              <a:t> </a:t>
+            </a:r>
+            <a:r>
+              <a:rPr sz="2600" b="1" i="0" dirty="0" err="1">
+                <a:solidFill>
+                  <a:srgbClr val="2E86AB"/>
+                </a:solidFill>
+                <a:latin typeface="Calibri"/>
+              </a:rPr>
+              <a:t>ככל</a:t>
+            </a:r>
+            <a:r>
+              <a:rPr sz="2600" b="1" i="0" dirty="0">
+                <a:solidFill>
+                  <a:srgbClr val="2E86AB"/>
+                </a:solidFill>
+                <a:latin typeface="Calibri"/>
+              </a:rPr>
+              <a:t> </a:t>
+            </a:r>
+            <a:r>
+              <a:rPr sz="2600" b="1" i="0" dirty="0" err="1">
+                <a:solidFill>
+                  <a:srgbClr val="2E86AB"/>
+                </a:solidFill>
+                <a:latin typeface="Calibri"/>
+              </a:rPr>
+              <a:t>שגודל</a:t>
+            </a:r>
+            <a:r>
+              <a:rPr sz="2600" b="1" i="0" dirty="0">
+                <a:solidFill>
+                  <a:srgbClr val="2E86AB"/>
+                </a:solidFill>
+                <a:latin typeface="Calibri"/>
+              </a:rPr>
+              <a:t> </a:t>
+            </a:r>
+            <a:r>
+              <a:rPr sz="2600" b="1" i="0" dirty="0" err="1">
+                <a:solidFill>
+                  <a:srgbClr val="2E86AB"/>
+                </a:solidFill>
+                <a:latin typeface="Calibri"/>
+              </a:rPr>
+              <a:t>המדגם</a:t>
+            </a:r>
+            <a:r>
+              <a:rPr lang="en-US" sz="2600" b="1" i="0" dirty="0">
+                <a:solidFill>
+                  <a:srgbClr val="2E86AB"/>
+                </a:solidFill>
+                <a:latin typeface="Calibri"/>
+              </a:rPr>
+              <a:t>  n</a:t>
+            </a:r>
+            <a:r>
+              <a:rPr lang="en-US" sz="2600" b="1" dirty="0">
+                <a:solidFill>
+                  <a:srgbClr val="2E86AB"/>
+                </a:solidFill>
+                <a:latin typeface="Calibri"/>
+              </a:rPr>
+              <a:t> </a:t>
+            </a:r>
+            <a:r>
+              <a:rPr lang="he-IL" sz="2600" b="1" dirty="0">
+                <a:solidFill>
+                  <a:srgbClr val="2E86AB"/>
+                </a:solidFill>
+                <a:latin typeface="Calibri"/>
+              </a:rPr>
+              <a:t> גדל</a:t>
+            </a:r>
+            <a:r>
+              <a:rPr sz="2600" b="1" i="0" dirty="0">
+                <a:solidFill>
+                  <a:srgbClr val="2E86AB"/>
+                </a:solidFill>
+                <a:latin typeface="Calibri"/>
+              </a:rPr>
+              <a:t>.</a:t>
             </a:r>
           </a:p>
         </p:txBody>
@@ -4956,71 +5601,6 @@
                 <a:latin typeface="Calibri"/>
               </a:rPr>
               <a:t>שונות קטנה = אומד יציב ומדויק יותר.</a:t>
-            </a:r>
-          </a:p>
-        </p:txBody>
-      </p:sp>
-      <p:sp>
-        <p:nvSpPr>
-          <p:cNvPr id="10" name="TextBox 9"/>
-          <p:cNvSpPr txBox="1"/>
-          <p:nvPr/>
-        </p:nvSpPr>
-        <p:spPr>
-          <a:xfrm>
-            <a:off x="457200" y="6419088"/>
-            <a:ext cx="11274552" cy="320040"/>
-          </a:xfrm>
-          <a:prstGeom prst="rect">
-            <a:avLst/>
-          </a:prstGeom>
-          <a:noFill/>
-        </p:spPr>
-        <p:txBody>
-          <a:bodyPr wrap="square" anchor="t">
-            <a:spAutoFit/>
-          </a:bodyPr>
-          <a:lstStyle/>
-          <a:p>
-            <a:pPr algn="l" rtl="0">
-              <a:lnSpc>
-                <a:spcPct val="100000"/>
-              </a:lnSpc>
-              <a:spcBef>
-                <a:spcPts val="0"/>
-              </a:spcBef>
-              <a:spcAft>
-                <a:spcPts val="600"/>
-              </a:spcAft>
-            </a:pPr>
-            <a:r>
-              <a:rPr sz="1000" b="0" i="0">
-                <a:solidFill>
-                  <a:srgbClr val="5A6B7B"/>
-                </a:solidFill>
-                <a:latin typeface="Calibri"/>
-              </a:rPr>
-              <a:t>שיעור 3 ·</a:t>
-            </a:r>
-            <a:br/>
-            <a:r>
-              <a:rPr sz="1000" b="0" i="0">
-                <a:solidFill>
-                  <a:srgbClr val="5A6B7B"/>
-                </a:solidFill>
-                <a:latin typeface="Calibri"/>
-              </a:rPr>
-              <a:t>KPIs</a:t>
-            </a:r>
-            <a:br/>
-            <a:r>
-              <a:rPr sz="1000" b="0" i="0">
-                <a:solidFill>
-                  <a:srgbClr val="5A6B7B"/>
-                </a:solidFill>
-                <a:latin typeface="Calibri"/>
-              </a:rPr>
-              <a:t>ואומדים  ·  11</a:t>
             </a:r>
           </a:p>
         </p:txBody>
@@ -7077,8 +7657,8 @@
         </p:nvSpPr>
         <p:spPr>
           <a:xfrm>
-            <a:off x="822960" y="3236975"/>
-            <a:ext cx="10515600" cy="1033271"/>
+            <a:off x="822960" y="3408003"/>
+            <a:ext cx="10515600" cy="691215"/>
           </a:xfrm>
           <a:prstGeom prst="rect">
             <a:avLst/>
@@ -7140,7 +7720,16 @@
                 </a:solidFill>
                 <a:latin typeface="Calibri"/>
               </a:rPr>
-              <a:t>‪10‬ </a:t>
+              <a:t>10‬ </a:t>
+            </a:r>
+            <a:r>
+              <a:rPr lang="he-IL" sz="1500" b="0" i="0" dirty="0">
+                <a:solidFill>
+                  <a:srgbClr val="1A2433"/>
+                </a:solidFill>
+                <a:latin typeface="Calibri"/>
+              </a:rPr>
+              <a:t> </a:t>
             </a:r>
             <a:r>
               <a:rPr sz="1500" b="0" i="0" dirty="0" err="1">
@@ -11041,7 +11630,7 @@
         <p:spPr>
           <a:xfrm>
             <a:off x="457200" y="411480"/>
-            <a:ext cx="11274552" cy="411480"/>
+            <a:ext cx="11274552" cy="307777"/>
           </a:xfrm>
           <a:prstGeom prst="rect">
             <a:avLst/>
@@ -11072,7 +11661,25 @@
                 </a:solidFill>
                 <a:latin typeface="Calibri"/>
               </a:rPr>
-              <a:t>‪Confidence interval · R = 10 replications‬</a:t>
+              <a:t>‪Confidence interval · </a:t>
+            </a:r>
+            <a:r>
+              <a:rPr lang="en-US" sz="1400" b="1" i="0">
+                <a:solidFill>
+                  <a:srgbClr val="2E86AB"/>
+                </a:solidFill>
+                <a:latin typeface="Calibri"/>
+              </a:rPr>
+              <a:t>n = 10</a:t>
+            </a:r>
+            <a:r>
+              <a:rPr sz="1400" b="1" i="0">
+                <a:solidFill>
+                  <a:srgbClr val="2E86AB"/>
+                </a:solidFill>
+                <a:latin typeface="Calibri"/>
+              </a:rPr>
+              <a:t> replications‬</a:t>
             </a:r>
           </a:p>
         </p:txBody>
@@ -11168,30 +11775,6 @@
           </a:p>
         </p:txBody>
       </p:sp>
-      <p:pic>
-        <p:nvPicPr>
-          <p:cNvPr id="6" name="Picture 5" descr="ci_formula.png"/>
-          <p:cNvPicPr>
-            <a:picLocks noChangeAspect="1"/>
-          </p:cNvPicPr>
-          <p:nvPr/>
-        </p:nvPicPr>
-        <p:blipFill>
-          <a:blip r:embed="rId2"/>
-          <a:stretch>
-            <a:fillRect/>
-          </a:stretch>
-        </p:blipFill>
-        <p:spPr>
-          <a:xfrm>
-            <a:off x="3295171" y="1783080"/>
-            <a:ext cx="5601353" cy="1828800"/>
-          </a:xfrm>
-          <a:prstGeom prst="rect">
-            <a:avLst/>
-          </a:prstGeom>
-        </p:spPr>
-      </p:pic>
       <p:sp>
         <p:nvSpPr>
           <p:cNvPr id="7" name="Rounded Rectangle 6"/>
@@ -11507,6 +12090,36 @@
           </a:p>
         </p:txBody>
       </p:sp>
+      <p:pic>
+        <p:nvPicPr>
+          <p:cNvPr id="14" name="Picture 13">
+            <a:extLst>
+              <a:ext uri="{FF2B5EF4-FFF2-40B4-BE49-F238E27FC236}">
+                <a16:creationId xmlns:a16="http://schemas.microsoft.com/office/drawing/2014/main" id="{D2F538FF-962A-C13F-CAA6-6E4504406771}"/>
+              </a:ext>
+            </a:extLst>
+          </p:cNvPr>
+          <p:cNvPicPr>
+            <a:picLocks noChangeAspect="1"/>
+          </p:cNvPicPr>
+          <p:nvPr/>
+        </p:nvPicPr>
+        <p:blipFill>
+          <a:blip r:embed="rId2"/>
+          <a:stretch>
+            <a:fillRect/>
+          </a:stretch>
+        </p:blipFill>
+        <p:spPr>
+          <a:xfrm>
+            <a:off x="3198139" y="1783079"/>
+            <a:ext cx="5795723" cy="1828800"/>
+          </a:xfrm>
+          <a:prstGeom prst="rect">
+            <a:avLst/>
+          </a:prstGeom>
+        </p:spPr>
+      </p:pic>
     </p:spTree>
     <p:extLst>
       <p:ext uri="{BB962C8B-B14F-4D97-AF65-F5344CB8AC3E}">
@@ -19173,7 +19786,7 @@
                 </a:solidFill>
                 <a:latin typeface="Calibri"/>
               </a:rPr>
-              <a:t>100 · 4 ·</a:t>
+              <a:t>100 · 4 </a:t>
             </a:r>
             <a:r>
               <a:rPr lang="he-IL" sz="1500" b="0" i="0" dirty="0">
@@ -19182,7 +19795,7 @@
                 </a:solidFill>
                 <a:latin typeface="Calibri"/>
               </a:rPr>
-              <a:t>  </a:t>
+              <a:t> </a:t>
             </a:r>
             <a:r>
               <a:rPr sz="1500" b="0" i="0" dirty="0">
@@ -20209,7 +20822,7 @@
               </a:spcAft>
             </a:pPr>
             <a:r>
-              <a:rPr sz="1800" b="1" i="0">
+              <a:rPr sz="1800" b="1" i="0" dirty="0">
                 <a:solidFill>
                   <a:srgbClr val="1F3A5F"/>
                 </a:solidFill>
@@ -20231,13 +20844,130 @@
               </a:spcAft>
             </a:pPr>
             <a:r>
-              <a:rPr sz="1500" b="0" i="0">
-                <a:solidFill>
-                  <a:srgbClr val="1A2433"/>
-                </a:solidFill>
-                <a:latin typeface="Calibri"/>
-              </a:rPr>
-              <a:t>תלויה בתהליך סטוכסטי מורכב — בלי פתרון אנליטי.</a:t>
+              <a:rPr sz="1500" b="0" i="0" dirty="0" err="1">
+                <a:solidFill>
+                  <a:srgbClr val="1A2433"/>
+                </a:solidFill>
+                <a:latin typeface="Calibri"/>
+              </a:rPr>
+              <a:t>תלויה</a:t>
+            </a:r>
+            <a:r>
+              <a:rPr sz="1500" b="0" i="0" dirty="0">
+                <a:solidFill>
+                  <a:srgbClr val="1A2433"/>
+                </a:solidFill>
+                <a:latin typeface="Calibri"/>
+              </a:rPr>
+              <a:t> </a:t>
+            </a:r>
+            <a:r>
+              <a:rPr sz="1500" b="0" i="0" dirty="0" err="1">
+                <a:solidFill>
+                  <a:srgbClr val="1A2433"/>
+                </a:solidFill>
+                <a:latin typeface="Calibri"/>
+              </a:rPr>
+              <a:t>בתהליך</a:t>
+            </a:r>
+            <a:r>
+              <a:rPr sz="1500" b="0" i="0" dirty="0">
+                <a:solidFill>
+                  <a:srgbClr val="1A2433"/>
+                </a:solidFill>
+                <a:latin typeface="Calibri"/>
+              </a:rPr>
+              <a:t> </a:t>
+            </a:r>
+            <a:r>
+              <a:rPr sz="1500" b="0" i="0" dirty="0" err="1">
+                <a:solidFill>
+                  <a:srgbClr val="1A2433"/>
+                </a:solidFill>
+                <a:latin typeface="Calibri"/>
+              </a:rPr>
+              <a:t>סטוכסטי</a:t>
+            </a:r>
+            <a:r>
+              <a:rPr sz="1500" b="0" i="0" dirty="0">
+                <a:solidFill>
+                  <a:srgbClr val="1A2433"/>
+                </a:solidFill>
+                <a:latin typeface="Calibri"/>
+              </a:rPr>
+              <a:t> </a:t>
+            </a:r>
+            <a:r>
+              <a:rPr sz="1500" b="0" i="0" dirty="0" err="1">
+                <a:solidFill>
+                  <a:srgbClr val="1A2433"/>
+                </a:solidFill>
+                <a:latin typeface="Calibri"/>
+              </a:rPr>
+              <a:t>מורכב</a:t>
+            </a:r>
+            <a:r>
+              <a:rPr sz="1500" b="0" i="0" dirty="0">
+                <a:solidFill>
+                  <a:srgbClr val="1A2433"/>
+                </a:solidFill>
+                <a:latin typeface="Calibri"/>
+              </a:rPr>
+              <a:t> — </a:t>
+            </a:r>
+            <a:r>
+              <a:rPr sz="1500" b="0" i="0" dirty="0" err="1">
+                <a:solidFill>
+                  <a:srgbClr val="1A2433"/>
+                </a:solidFill>
+                <a:latin typeface="Calibri"/>
+              </a:rPr>
+              <a:t>בלי</a:t>
+            </a:r>
+            <a:r>
+              <a:rPr sz="1500" b="0" i="0" dirty="0">
+                <a:solidFill>
+                  <a:srgbClr val="1A2433"/>
+                </a:solidFill>
+                <a:latin typeface="Calibri"/>
+              </a:rPr>
+              <a:t> </a:t>
+            </a:r>
+            <a:r>
+              <a:rPr sz="1500" b="0" i="0" dirty="0" err="1">
+                <a:solidFill>
+                  <a:srgbClr val="1A2433"/>
+                </a:solidFill>
+                <a:latin typeface="Calibri"/>
+              </a:rPr>
+              <a:t>פתרון</a:t>
+            </a:r>
+            <a:r>
+              <a:rPr sz="1500" b="0" i="0" dirty="0">
+                <a:solidFill>
+                  <a:srgbClr val="1A2433"/>
+                </a:solidFill>
+                <a:latin typeface="Calibri"/>
+              </a:rPr>
+              <a:t> </a:t>
+            </a:r>
+            <a:r>
+              <a:rPr sz="1500" b="0" i="0" dirty="0" err="1">
+                <a:solidFill>
+                  <a:srgbClr val="1A2433"/>
+                </a:solidFill>
+                <a:latin typeface="Calibri"/>
+              </a:rPr>
+              <a:t>אנליטי</a:t>
+            </a:r>
+            <a:r>
+              <a:rPr sz="1500" b="0" i="0" dirty="0">
+                <a:solidFill>
+                  <a:srgbClr val="1A2433"/>
+                </a:solidFill>
+                <a:latin typeface="Calibri"/>
+              </a:rPr>
+              <a:t>.</a:t>
             </a:r>
           </a:p>
         </p:txBody>
@@ -20325,13 +21055,40 @@
               </a:spcAft>
             </a:pPr>
             <a:r>
-              <a:rPr sz="1800" b="1" i="0">
+              <a:rPr sz="1800" b="1" i="0" dirty="0" err="1">
                 <a:solidFill>
                   <a:srgbClr val="1F3A5F"/>
                 </a:solidFill>
                 <a:latin typeface="Calibri"/>
               </a:rPr>
-              <a:t>הרעיון הכללי  </a:t>
+              <a:t>הרעיון</a:t>
+            </a:r>
+            <a:r>
+              <a:rPr sz="1800" b="1" i="0" dirty="0">
+                <a:solidFill>
+                  <a:srgbClr val="1F3A5F"/>
+                </a:solidFill>
+                <a:latin typeface="Calibri"/>
+              </a:rPr>
+              <a:t> </a:t>
+            </a:r>
+            <a:r>
+              <a:rPr sz="1800" b="1" i="0" dirty="0" err="1">
+                <a:solidFill>
+                  <a:srgbClr val="1F3A5F"/>
+                </a:solidFill>
+                <a:latin typeface="Calibri"/>
+              </a:rPr>
+              <a:t>הכללי</a:t>
+            </a:r>
+            <a:r>
+              <a:rPr sz="1800" b="1" i="0" dirty="0">
+                <a:solidFill>
+                  <a:srgbClr val="1F3A5F"/>
+                </a:solidFill>
+                <a:latin typeface="Calibri"/>
+              </a:rPr>
+              <a:t>  </a:t>
             </a:r>
           </a:p>
           <a:p>
@@ -20347,13 +21104,166 @@
               </a:spcAft>
             </a:pPr>
             <a:r>
-              <a:rPr sz="1500" b="0" i="0">
-                <a:solidFill>
-                  <a:srgbClr val="1A2433"/>
-                </a:solidFill>
-                <a:latin typeface="Calibri"/>
-              </a:rPr>
-              <a:t>מנסחים פונקציית עלות, ואת המדד הסטוכסטי שבתוכה משערכים בסימולציה.</a:t>
+              <a:rPr sz="1500" b="0" i="0" dirty="0" err="1">
+                <a:solidFill>
+                  <a:srgbClr val="1A2433"/>
+                </a:solidFill>
+                <a:latin typeface="Calibri"/>
+              </a:rPr>
+              <a:t>מנסחים</a:t>
+            </a:r>
+            <a:r>
+              <a:rPr sz="1500" b="0" i="0" dirty="0">
+                <a:solidFill>
+                  <a:srgbClr val="1A2433"/>
+                </a:solidFill>
+                <a:latin typeface="Calibri"/>
+              </a:rPr>
+              <a:t> </a:t>
+            </a:r>
+            <a:r>
+              <a:rPr sz="1500" b="0" i="0" dirty="0" err="1">
+                <a:solidFill>
+                  <a:srgbClr val="1A2433"/>
+                </a:solidFill>
+                <a:latin typeface="Calibri"/>
+              </a:rPr>
+              <a:t>פונקציית</a:t>
+            </a:r>
+            <a:r>
+              <a:rPr sz="1500" b="0" i="0" dirty="0">
+                <a:solidFill>
+                  <a:srgbClr val="1A2433"/>
+                </a:solidFill>
+                <a:latin typeface="Calibri"/>
+              </a:rPr>
+              <a:t> </a:t>
+            </a:r>
+            <a:r>
+              <a:rPr sz="1500" b="0" i="0" dirty="0" err="1">
+                <a:solidFill>
+                  <a:srgbClr val="1A2433"/>
+                </a:solidFill>
+                <a:latin typeface="Calibri"/>
+              </a:rPr>
+              <a:t>עלות</a:t>
+            </a:r>
+            <a:r>
+              <a:rPr sz="1500" b="0" i="0" dirty="0">
+                <a:solidFill>
+                  <a:srgbClr val="1A2433"/>
+                </a:solidFill>
+                <a:latin typeface="Calibri"/>
+              </a:rPr>
+              <a:t>, </a:t>
+            </a:r>
+            <a:r>
+              <a:rPr sz="1500" b="0" i="0" dirty="0" err="1">
+                <a:solidFill>
+                  <a:srgbClr val="1A2433"/>
+                </a:solidFill>
+                <a:latin typeface="Calibri"/>
+              </a:rPr>
+              <a:t>ואת</a:t>
+            </a:r>
+            <a:r>
+              <a:rPr sz="1500" b="0" i="0" dirty="0">
+                <a:solidFill>
+                  <a:srgbClr val="1A2433"/>
+                </a:solidFill>
+                <a:latin typeface="Calibri"/>
+              </a:rPr>
+              <a:t> </a:t>
+            </a:r>
+            <a:r>
+              <a:rPr sz="1500" b="0" i="0" dirty="0" err="1">
+                <a:solidFill>
+                  <a:srgbClr val="1A2433"/>
+                </a:solidFill>
+                <a:latin typeface="Calibri"/>
+              </a:rPr>
+              <a:t>המדד</a:t>
+            </a:r>
+            <a:r>
+              <a:rPr sz="1500" b="0" i="0" dirty="0">
+                <a:solidFill>
+                  <a:srgbClr val="1A2433"/>
+                </a:solidFill>
+                <a:latin typeface="Calibri"/>
+              </a:rPr>
+              <a:t> </a:t>
+            </a:r>
+            <a:r>
+              <a:rPr sz="1500" b="0" i="0" dirty="0" err="1">
+                <a:solidFill>
+                  <a:srgbClr val="1A2433"/>
+                </a:solidFill>
+                <a:latin typeface="Calibri"/>
+              </a:rPr>
+              <a:t>הסטוכסטי</a:t>
+            </a:r>
+            <a:r>
+              <a:rPr sz="1500" b="0" i="0" dirty="0">
+                <a:solidFill>
+                  <a:srgbClr val="1A2433"/>
+                </a:solidFill>
+                <a:latin typeface="Calibri"/>
+              </a:rPr>
+              <a:t> </a:t>
+            </a:r>
+            <a:r>
+              <a:rPr sz="1500" b="0" i="0" dirty="0" err="1">
+                <a:solidFill>
+                  <a:srgbClr val="1A2433"/>
+                </a:solidFill>
+                <a:latin typeface="Calibri"/>
+              </a:rPr>
+              <a:t>שבתוכה</a:t>
+            </a:r>
+            <a:r>
+              <a:rPr sz="1500" b="0" i="0" dirty="0">
+                <a:solidFill>
+                  <a:srgbClr val="1A2433"/>
+                </a:solidFill>
+                <a:latin typeface="Calibri"/>
+              </a:rPr>
+              <a:t> </a:t>
+            </a:r>
+            <a:r>
+              <a:rPr sz="1500" b="0" i="0" dirty="0" err="1">
+                <a:solidFill>
+                  <a:srgbClr val="1A2433"/>
+                </a:solidFill>
+                <a:latin typeface="Calibri"/>
+              </a:rPr>
+              <a:t>משערכים</a:t>
+            </a:r>
+            <a:r>
+              <a:rPr sz="1500" b="0" i="0" dirty="0">
+                <a:solidFill>
+                  <a:srgbClr val="1A2433"/>
+                </a:solidFill>
+                <a:latin typeface="Calibri"/>
+              </a:rPr>
+              <a:t> </a:t>
+            </a:r>
+            <a:r>
+              <a:rPr sz="1500" b="0" i="0" dirty="0" err="1">
+                <a:solidFill>
+                  <a:srgbClr val="1A2433"/>
+                </a:solidFill>
+                <a:latin typeface="Calibri"/>
+              </a:rPr>
+              <a:t>בסימולציה</a:t>
+            </a:r>
+            <a:r>
+              <a:rPr sz="1500" b="0" i="0" dirty="0">
+                <a:solidFill>
+                  <a:srgbClr val="1A2433"/>
+                </a:solidFill>
+                <a:latin typeface="Calibri"/>
+              </a:rPr>
+              <a:t>.</a:t>
             </a:r>
           </a:p>
         </p:txBody>
@@ -20428,6 +21338,254 @@
   <p:clrMapOvr>
     <a:masterClrMapping/>
   </p:clrMapOvr>
+  <p:timing>
+    <p:tnLst>
+      <p:par>
+        <p:cTn id="1" dur="indefinite" restart="never" nodeType="tmRoot">
+          <p:childTnLst>
+            <p:seq concurrent="1" nextAc="seek">
+              <p:cTn id="2" dur="indefinite" nodeType="mainSeq">
+                <p:childTnLst>
+                  <p:par>
+                    <p:cTn id="3" fill="hold">
+                      <p:stCondLst>
+                        <p:cond delay="indefinite"/>
+                      </p:stCondLst>
+                      <p:childTnLst>
+                        <p:par>
+                          <p:cTn id="4" fill="hold">
+                            <p:stCondLst>
+                              <p:cond delay="0"/>
+                            </p:stCondLst>
+                            <p:childTnLst>
+                              <p:par>
+                                <p:cTn id="5" presetID="10" presetClass="entr" presetSubtype="0" fill="hold" grpId="0" nodeType="clickEffect">
+                                  <p:stCondLst>
+                                    <p:cond delay="0"/>
+                                  </p:stCondLst>
+                                  <p:childTnLst>
+                                    <p:set>
+                                      <p:cBhvr>
+                                        <p:cTn id="6" dur="1" fill="hold">
+                                          <p:stCondLst>
+                                            <p:cond delay="0"/>
+                                          </p:stCondLst>
+                                        </p:cTn>
+                                        <p:tgtEl>
+                                          <p:spTgt spid="7"/>
+                                        </p:tgtEl>
+                                        <p:attrNameLst>
+                                          <p:attrName>style.visibility</p:attrName>
+                                        </p:attrNameLst>
+                                      </p:cBhvr>
+                                      <p:to>
+                                        <p:strVal val="visible"/>
+                                      </p:to>
+                                    </p:set>
+                                    <p:animEffect transition="in" filter="fade">
+                                      <p:cBhvr>
+                                        <p:cTn id="7" dur="500"/>
+                                        <p:tgtEl>
+                                          <p:spTgt spid="7"/>
+                                        </p:tgtEl>
+                                      </p:cBhvr>
+                                    </p:animEffect>
+                                  </p:childTnLst>
+                                </p:cTn>
+                              </p:par>
+                            </p:childTnLst>
+                          </p:cTn>
+                        </p:par>
+                      </p:childTnLst>
+                    </p:cTn>
+                  </p:par>
+                  <p:par>
+                    <p:cTn id="8" fill="hold">
+                      <p:stCondLst>
+                        <p:cond delay="indefinite"/>
+                      </p:stCondLst>
+                      <p:childTnLst>
+                        <p:par>
+                          <p:cTn id="9" fill="hold">
+                            <p:stCondLst>
+                              <p:cond delay="0"/>
+                            </p:stCondLst>
+                            <p:childTnLst>
+                              <p:par>
+                                <p:cTn id="10" presetID="10" presetClass="entr" presetSubtype="0" fill="hold" grpId="0" nodeType="clickEffect">
+                                  <p:stCondLst>
+                                    <p:cond delay="0"/>
+                                  </p:stCondLst>
+                                  <p:childTnLst>
+                                    <p:set>
+                                      <p:cBhvr>
+                                        <p:cTn id="11" dur="1" fill="hold">
+                                          <p:stCondLst>
+                                            <p:cond delay="0"/>
+                                          </p:stCondLst>
+                                        </p:cTn>
+                                        <p:tgtEl>
+                                          <p:spTgt spid="9"/>
+                                        </p:tgtEl>
+                                        <p:attrNameLst>
+                                          <p:attrName>style.visibility</p:attrName>
+                                        </p:attrNameLst>
+                                      </p:cBhvr>
+                                      <p:to>
+                                        <p:strVal val="visible"/>
+                                      </p:to>
+                                    </p:set>
+                                    <p:animEffect transition="in" filter="fade">
+                                      <p:cBhvr>
+                                        <p:cTn id="12" dur="500"/>
+                                        <p:tgtEl>
+                                          <p:spTgt spid="9"/>
+                                        </p:tgtEl>
+                                      </p:cBhvr>
+                                    </p:animEffect>
+                                  </p:childTnLst>
+                                </p:cTn>
+                              </p:par>
+                            </p:childTnLst>
+                          </p:cTn>
+                        </p:par>
+                      </p:childTnLst>
+                    </p:cTn>
+                  </p:par>
+                  <p:par>
+                    <p:cTn id="13" fill="hold">
+                      <p:stCondLst>
+                        <p:cond delay="indefinite"/>
+                      </p:stCondLst>
+                      <p:childTnLst>
+                        <p:par>
+                          <p:cTn id="14" fill="hold">
+                            <p:stCondLst>
+                              <p:cond delay="0"/>
+                            </p:stCondLst>
+                            <p:childTnLst>
+                              <p:par>
+                                <p:cTn id="15" presetID="10" presetClass="entr" presetSubtype="0" fill="hold" grpId="0" nodeType="clickEffect">
+                                  <p:stCondLst>
+                                    <p:cond delay="0"/>
+                                  </p:stCondLst>
+                                  <p:childTnLst>
+                                    <p:set>
+                                      <p:cBhvr>
+                                        <p:cTn id="16" dur="1" fill="hold">
+                                          <p:stCondLst>
+                                            <p:cond delay="0"/>
+                                          </p:stCondLst>
+                                        </p:cTn>
+                                        <p:tgtEl>
+                                          <p:spTgt spid="11"/>
+                                        </p:tgtEl>
+                                        <p:attrNameLst>
+                                          <p:attrName>style.visibility</p:attrName>
+                                        </p:attrNameLst>
+                                      </p:cBhvr>
+                                      <p:to>
+                                        <p:strVal val="visible"/>
+                                      </p:to>
+                                    </p:set>
+                                    <p:animEffect transition="in" filter="fade">
+                                      <p:cBhvr>
+                                        <p:cTn id="17" dur="500"/>
+                                        <p:tgtEl>
+                                          <p:spTgt spid="11"/>
+                                        </p:tgtEl>
+                                      </p:cBhvr>
+                                    </p:animEffect>
+                                  </p:childTnLst>
+                                </p:cTn>
+                              </p:par>
+                            </p:childTnLst>
+                          </p:cTn>
+                        </p:par>
+                      </p:childTnLst>
+                    </p:cTn>
+                  </p:par>
+                  <p:par>
+                    <p:cTn id="18" fill="hold">
+                      <p:stCondLst>
+                        <p:cond delay="indefinite"/>
+                      </p:stCondLst>
+                      <p:childTnLst>
+                        <p:par>
+                          <p:cTn id="19" fill="hold">
+                            <p:stCondLst>
+                              <p:cond delay="0"/>
+                            </p:stCondLst>
+                            <p:childTnLst>
+                              <p:par>
+                                <p:cTn id="20" presetID="10" presetClass="entr" presetSubtype="0" fill="hold" grpId="0" nodeType="clickEffect">
+                                  <p:stCondLst>
+                                    <p:cond delay="0"/>
+                                  </p:stCondLst>
+                                  <p:childTnLst>
+                                    <p:set>
+                                      <p:cBhvr>
+                                        <p:cTn id="21" dur="1" fill="hold">
+                                          <p:stCondLst>
+                                            <p:cond delay="0"/>
+                                          </p:stCondLst>
+                                        </p:cTn>
+                                        <p:tgtEl>
+                                          <p:spTgt spid="13"/>
+                                        </p:tgtEl>
+                                        <p:attrNameLst>
+                                          <p:attrName>style.visibility</p:attrName>
+                                        </p:attrNameLst>
+                                      </p:cBhvr>
+                                      <p:to>
+                                        <p:strVal val="visible"/>
+                                      </p:to>
+                                    </p:set>
+                                    <p:animEffect transition="in" filter="fade">
+                                      <p:cBhvr>
+                                        <p:cTn id="22" dur="500"/>
+                                        <p:tgtEl>
+                                          <p:spTgt spid="13"/>
+                                        </p:tgtEl>
+                                      </p:cBhvr>
+                                    </p:animEffect>
+                                  </p:childTnLst>
+                                </p:cTn>
+                              </p:par>
+                            </p:childTnLst>
+                          </p:cTn>
+                        </p:par>
+                      </p:childTnLst>
+                    </p:cTn>
+                  </p:par>
+                </p:childTnLst>
+              </p:cTn>
+              <p:prevCondLst>
+                <p:cond evt="onPrev" delay="0">
+                  <p:tgtEl>
+                    <p:sldTgt/>
+                  </p:tgtEl>
+                </p:cond>
+              </p:prevCondLst>
+              <p:nextCondLst>
+                <p:cond evt="onNext" delay="0">
+                  <p:tgtEl>
+                    <p:sldTgt/>
+                  </p:tgtEl>
+                </p:cond>
+              </p:nextCondLst>
+            </p:seq>
+          </p:childTnLst>
+        </p:cTn>
+      </p:par>
+    </p:tnLst>
+    <p:bldLst>
+      <p:bldP spid="7" grpId="0"/>
+      <p:bldP spid="9" grpId="0"/>
+      <p:bldP spid="11" grpId="0"/>
+      <p:bldP spid="13" grpId="0"/>
+    </p:bldLst>
+  </p:timing>
 </p:sld>
 </file>
 
@@ -25354,4 +26512,319 @@
   </a:objectDefaults>
   <a:extraClrSchemeLst/>
 </a:theme>
+</file>
+
+<file path=ppt/theme/theme2.xml><?xml version="1.0" encoding="utf-8"?>
+<a:theme xmlns:a="http://schemas.openxmlformats.org/drawingml/2006/main" name="Office Theme">
+  <a:themeElements>
+    <a:clrScheme name="Office">
+      <a:dk1>
+        <a:sysClr val="windowText" lastClr="000000"/>
+      </a:dk1>
+      <a:lt1>
+        <a:sysClr val="window" lastClr="FFFFFF"/>
+      </a:lt1>
+      <a:dk2>
+        <a:srgbClr val="0E2841"/>
+      </a:dk2>
+      <a:lt2>
+        <a:srgbClr val="E8E8E8"/>
+      </a:lt2>
+      <a:accent1>
+        <a:srgbClr val="156082"/>
+      </a:accent1>
+      <a:accent2>
+        <a:srgbClr val="E97132"/>
+      </a:accent2>
+      <a:accent3>
+        <a:srgbClr val="196B24"/>
+      </a:accent3>
+      <a:accent4>
+        <a:srgbClr val="0F9ED5"/>
+      </a:accent4>
+      <a:accent5>
+        <a:srgbClr val="A02B93"/>
+      </a:accent5>
+      <a:accent6>
+        <a:srgbClr val="4EA72E"/>
+      </a:accent6>
+      <a:hlink>
+        <a:srgbClr val="467886"/>
+      </a:hlink>
+      <a:folHlink>
+        <a:srgbClr val="96607D"/>
+      </a:folHlink>
+    </a:clrScheme>
+    <a:fontScheme name="Office">
+      <a:majorFont>
+        <a:latin typeface="Aptos Display" panose="02110004020202020204"/>
+        <a:ea typeface=""/>
+        <a:cs typeface=""/>
+        <a:font script="Jpan" typeface="游ゴシック Light"/>
+        <a:font script="Hang" typeface="맑은 고딕"/>
+        <a:font script="Hans" typeface="等线 Light"/>
+        <a:font script="Hant" typeface="新細明體"/>
+        <a:font script="Arab" typeface="Times New Roman"/>
+        <a:font script="Hebr" typeface="Times New Roman"/>
+        <a:font script="Thai" typeface="Angsana New"/>
+        <a:font script="Ethi" typeface="Nyala"/>
+        <a:font script="Beng" typeface="Vrinda"/>
+        <a:font script="Gujr" typeface="Shruti"/>
+        <a:font script="Khmr" typeface="MoolBoran"/>
+        <a:font script="Knda" typeface="Tunga"/>
+        <a:font script="Guru" typeface="Raavi"/>
+        <a:font script="Cans" typeface="Euphemia"/>
+        <a:font script="Cher" typeface="Plantagenet Cherokee"/>
+        <a:font script="Yiii" typeface="Microsoft Yi Baiti"/>
+        <a:font script="Tibt" typeface="Microsoft Himalaya"/>
+        <a:font script="Thaa" typeface="MV Boli"/>
+        <a:font script="Deva" typeface="Mangal"/>
+        <a:font script="Telu" typeface="Gautami"/>
+        <a:font script="Taml" typeface="Latha"/>
+        <a:font script="Syrc" typeface="Estrangelo Edessa"/>
+        <a:font script="Orya" typeface="Kalinga"/>
+        <a:font script="Mlym" typeface="Kartika"/>
+        <a:font script="Laoo" typeface="DokChampa"/>
+        <a:font script="Sinh" typeface="Iskoola Pota"/>
+        <a:font script="Mong" typeface="Mongolian Baiti"/>
+        <a:font script="Viet" typeface="Times New Roman"/>
+        <a:font script="Uigh" typeface="Microsoft Uighur"/>
+        <a:font script="Geor" typeface="Sylfaen"/>
+        <a:font script="Armn" typeface="Arial"/>
+        <a:font script="Bugi" typeface="Leelawadee UI"/>
+        <a:font script="Bopo" typeface="Microsoft JhengHei"/>
+        <a:font script="Java" typeface="Javanese Text"/>
+        <a:font script="Lisu" typeface="Segoe UI"/>
+        <a:font script="Mymr" typeface="Myanmar Text"/>
+        <a:font script="Nkoo" typeface="Ebrima"/>
+        <a:font script="Olck" typeface="Nirmala UI"/>
+        <a:font script="Osma" typeface="Ebrima"/>
+        <a:font script="Phag" typeface="Phagspa"/>
+        <a:font script="Syrn" typeface="Estrangelo Edessa"/>
+        <a:font script="Syrj" typeface="Estrangelo Edessa"/>
+        <a:font script="Syre" typeface="Estrangelo Edessa"/>
+        <a:font script="Sora" typeface="Nirmala UI"/>
+        <a:font script="Tale" typeface="Microsoft Tai Le"/>
+        <a:font script="Talu" typeface="Microsoft New Tai Lue"/>
+        <a:font script="Tfng" typeface="Ebrima"/>
+      </a:majorFont>
+      <a:minorFont>
+        <a:latin typeface="Aptos" panose="02110004020202020204"/>
+        <a:ea typeface=""/>
+        <a:cs typeface=""/>
+        <a:font script="Jpan" typeface="游ゴシック"/>
+        <a:font script="Hang" typeface="맑은 고딕"/>
+        <a:font script="Hans" typeface="等线"/>
+        <a:font script="Hant" typeface="新細明體"/>
+        <a:font script="Arab" typeface="Arial"/>
+        <a:font script="Hebr" typeface="Arial"/>
+        <a:font script="Thai" typeface="Cordia New"/>
+        <a:font script="Ethi" typeface="Nyala"/>
+        <a:font script="Beng" typeface="Vrinda"/>
+        <a:font script="Gujr" typeface="Shruti"/>
+        <a:font script="Khmr" typeface="DaunPenh"/>
+        <a:font script="Knda" typeface="Tunga"/>
+        <a:font script="Guru" typeface="Raavi"/>
+        <a:font script="Cans" typeface="Euphemia"/>
+        <a:font script="Cher" typeface="Plantagenet Cherokee"/>
+        <a:font script="Yiii" typeface="Microsoft Yi Baiti"/>
+        <a:font script="Tibt" typeface="Microsoft Himalaya"/>
+        <a:font script="Thaa" typeface="MV Boli"/>
+        <a:font script="Deva" typeface="Mangal"/>
+        <a:font script="Telu" typeface="Gautami"/>
+        <a:font script="Taml" typeface="Latha"/>
+        <a:font script="Syrc" typeface="Estrangelo Edessa"/>
+        <a:font script="Orya" typeface="Kalinga"/>
+        <a:font script="Mlym" typeface="Kartika"/>
+        <a:font script="Laoo" typeface="DokChampa"/>
+        <a:font script="Sinh" typeface="Iskoola Pota"/>
+        <a:font script="Mong" typeface="Mongolian Baiti"/>
+        <a:font script="Viet" typeface="Arial"/>
+        <a:font script="Uigh" typeface="Microsoft Uighur"/>
+        <a:font script="Geor" typeface="Sylfaen"/>
+        <a:font script="Armn" typeface="Arial"/>
+        <a:font script="Bugi" typeface="Leelawadee UI"/>
+        <a:font script="Bopo" typeface="Microsoft JhengHei"/>
+        <a:font script="Java" typeface="Javanese Text"/>
+        <a:font script="Lisu" typeface="Segoe UI"/>
+        <a:font script="Mymr" typeface="Myanmar Text"/>
+        <a:font script="Nkoo" typeface="Ebrima"/>
+        <a:font script="Olck" typeface="Nirmala UI"/>
+        <a:font script="Osma" typeface="Ebrima"/>
+        <a:font script="Phag" typeface="Phagspa"/>
+        <a:font script="Syrn" typeface="Estrangelo Edessa"/>
+        <a:font script="Syrj" typeface="Estrangelo Edessa"/>
+        <a:font script="Syre" typeface="Estrangelo Edessa"/>
+        <a:font script="Sora" typeface="Nirmala UI"/>
+        <a:font script="Tale" typeface="Microsoft Tai Le"/>
+        <a:font script="Talu" typeface="Microsoft New Tai Lue"/>
+        <a:font script="Tfng" typeface="Ebrima"/>
+      </a:minorFont>
+    </a:fontScheme>
+    <a:fmtScheme name="Office">
+      <a:fillStyleLst>
+        <a:solidFill>
+          <a:schemeClr val="phClr"/>
+        </a:solidFill>
+        <a:gradFill rotWithShape="1">
+          <a:gsLst>
+            <a:gs pos="0">
+              <a:schemeClr val="phClr">
+                <a:lumMod val="110000"/>
+                <a:satMod val="105000"/>
+                <a:tint val="67000"/>
+              </a:schemeClr>
+            </a:gs>
+            <a:gs pos="50000">
+              <a:schemeClr val="phClr">
+                <a:lumMod val="105000"/>
+                <a:satMod val="103000"/>
+                <a:tint val="73000"/>
+              </a:schemeClr>
+            </a:gs>
+            <a:gs pos="100000">
+              <a:schemeClr val="phClr">
+                <a:lumMod val="105000"/>
+                <a:satMod val="109000"/>
+                <a:tint val="81000"/>
+              </a:schemeClr>
+            </a:gs>
+          </a:gsLst>
+          <a:lin ang="5400000" scaled="0"/>
+        </a:gradFill>
+        <a:gradFill rotWithShape="1">
+          <a:gsLst>
+            <a:gs pos="0">
+              <a:schemeClr val="phClr">
+                <a:satMod val="103000"/>
+                <a:lumMod val="102000"/>
+                <a:tint val="94000"/>
+              </a:schemeClr>
+            </a:gs>
+            <a:gs pos="50000">
+              <a:schemeClr val="phClr">
+                <a:satMod val="110000"/>
+                <a:lumMod val="100000"/>
+                <a:shade val="100000"/>
+              </a:schemeClr>
+            </a:gs>
+            <a:gs pos="100000">
+              <a:schemeClr val="phClr">
+                <a:lumMod val="99000"/>
+                <a:satMod val="120000"/>
+                <a:shade val="78000"/>
+              </a:schemeClr>
+            </a:gs>
+          </a:gsLst>
+          <a:lin ang="5400000" scaled="0"/>
+        </a:gradFill>
+      </a:fillStyleLst>
+      <a:lnStyleLst>
+        <a:ln w="12700" cap="flat" cmpd="sng" algn="ctr">
+          <a:solidFill>
+            <a:schemeClr val="phClr"/>
+          </a:solidFill>
+          <a:prstDash val="solid"/>
+          <a:miter lim="800000"/>
+        </a:ln>
+        <a:ln w="19050" cap="flat" cmpd="sng" algn="ctr">
+          <a:solidFill>
+            <a:schemeClr val="phClr"/>
+          </a:solidFill>
+          <a:prstDash val="solid"/>
+          <a:miter lim="800000"/>
+        </a:ln>
+        <a:ln w="25400" cap="flat" cmpd="sng" algn="ctr">
+          <a:solidFill>
+            <a:schemeClr val="phClr"/>
+          </a:solidFill>
+          <a:prstDash val="solid"/>
+          <a:miter lim="800000"/>
+        </a:ln>
+      </a:lnStyleLst>
+      <a:effectStyleLst>
+        <a:effectStyle>
+          <a:effectLst/>
+        </a:effectStyle>
+        <a:effectStyle>
+          <a:effectLst/>
+        </a:effectStyle>
+        <a:effectStyle>
+          <a:effectLst>
+            <a:outerShdw blurRad="57150" dist="19050" dir="5400000" algn="ctr" rotWithShape="0">
+              <a:srgbClr val="000000">
+                <a:alpha val="63000"/>
+              </a:srgbClr>
+            </a:outerShdw>
+          </a:effectLst>
+        </a:effectStyle>
+      </a:effectStyleLst>
+      <a:bgFillStyleLst>
+        <a:solidFill>
+          <a:schemeClr val="phClr"/>
+        </a:solidFill>
+        <a:solidFill>
+          <a:schemeClr val="phClr">
+            <a:tint val="95000"/>
+            <a:satMod val="170000"/>
+          </a:schemeClr>
+        </a:solidFill>
+        <a:gradFill rotWithShape="1">
+          <a:gsLst>
+            <a:gs pos="0">
+              <a:schemeClr val="phClr">
+                <a:tint val="93000"/>
+                <a:satMod val="150000"/>
+                <a:shade val="98000"/>
+                <a:lumMod val="102000"/>
+              </a:schemeClr>
+            </a:gs>
+            <a:gs pos="50000">
+              <a:schemeClr val="phClr">
+                <a:tint val="98000"/>
+                <a:satMod val="130000"/>
+                <a:shade val="90000"/>
+                <a:lumMod val="103000"/>
+              </a:schemeClr>
+            </a:gs>
+            <a:gs pos="100000">
+              <a:schemeClr val="phClr">
+                <a:shade val="63000"/>
+                <a:satMod val="120000"/>
+              </a:schemeClr>
+            </a:gs>
+          </a:gsLst>
+          <a:lin ang="5400000" scaled="0"/>
+        </a:gradFill>
+      </a:bgFillStyleLst>
+    </a:fmtScheme>
+  </a:themeElements>
+  <a:objectDefaults>
+    <a:lnDef>
+      <a:spPr/>
+      <a:bodyPr/>
+      <a:lstStyle/>
+      <a:style>
+        <a:lnRef idx="2">
+          <a:schemeClr val="accent1"/>
+        </a:lnRef>
+        <a:fillRef idx="0">
+          <a:schemeClr val="accent1"/>
+        </a:fillRef>
+        <a:effectRef idx="1">
+          <a:schemeClr val="accent1"/>
+        </a:effectRef>
+        <a:fontRef idx="minor">
+          <a:schemeClr val="tx1"/>
+        </a:fontRef>
+      </a:style>
+    </a:lnDef>
+  </a:objectDefaults>
+  <a:extraClrSchemeLst/>
+  <a:extLst>
+    <a:ext uri="{05A4C25C-085E-4340-85A3-A5531E510DB2}">
+      <thm15:themeFamily xmlns:thm15="http://schemas.microsoft.com/office/thememl/2012/main" name="Office Theme" id="{2E142A2C-CD16-42D6-873A-C26D2A0506FA}" vid="{1BDDFF52-6CD6-40A5-AB3C-68EB2F1E4D0A}"/>
+    </a:ext>
+  </a:extLst>
+</a:theme>
 </file>
</xml_diff>